<commit_message>
presentations all in fresh, gpt examples
</commit_message>
<xml_diff>
--- a/praksa/RAST/izradaprezentacije/Sigurnost_na_internetu_prezentacija.pptx
+++ b/praksa/RAST/izradaprezentacije/Sigurnost_na_internetu_prezentacija.pptx
@@ -5,7 +5,7 @@
     <p:sldMasterId id="2147483648" r:id="rId1"/>
   </p:sldMasterIdLst>
   <p:notesMasterIdLst>
-    <p:notesMasterId r:id="rId18"/>
+    <p:notesMasterId r:id="rId19"/>
   </p:notesMasterIdLst>
   <p:sldIdLst>
     <p:sldId id="256" r:id="rId2"/>
@@ -17,13 +17,14 @@
     <p:sldId id="261" r:id="rId8"/>
     <p:sldId id="262" r:id="rId9"/>
     <p:sldId id="263" r:id="rId10"/>
-    <p:sldId id="264" r:id="rId11"/>
-    <p:sldId id="265" r:id="rId12"/>
-    <p:sldId id="266" r:id="rId13"/>
-    <p:sldId id="267" r:id="rId14"/>
-    <p:sldId id="268" r:id="rId15"/>
-    <p:sldId id="269" r:id="rId16"/>
-    <p:sldId id="270" r:id="rId17"/>
+    <p:sldId id="276" r:id="rId11"/>
+    <p:sldId id="264" r:id="rId12"/>
+    <p:sldId id="265" r:id="rId13"/>
+    <p:sldId id="266" r:id="rId14"/>
+    <p:sldId id="267" r:id="rId15"/>
+    <p:sldId id="268" r:id="rId16"/>
+    <p:sldId id="269" r:id="rId17"/>
+    <p:sldId id="270" r:id="rId18"/>
   </p:sldIdLst>
   <p:sldSz cx="9144000" cy="5143500" type="screen16x9"/>
   <p:notesSz cx="5143500" cy="9144000"/>
@@ -401,7 +402,7 @@
           <a:p>
             <a:fld id="{F7021451-1387-4CA6-816F-3879F97B5CBC}" type="slidenum">
               <a:rPr lang="en-US"/>
-              <a:t>10</a:t>
+              <a:t>11</a:t>
             </a:fld>
             <a:endParaRPr lang="en-US"/>
           </a:p>
@@ -485,7 +486,7 @@
           <a:p>
             <a:fld id="{F7021451-1387-4CA6-816F-3879F97B5CBC}" type="slidenum">
               <a:rPr lang="en-US"/>
-              <a:t>11</a:t>
+              <a:t>12</a:t>
             </a:fld>
             <a:endParaRPr lang="en-US"/>
           </a:p>
@@ -569,7 +570,7 @@
           <a:p>
             <a:fld id="{F7021451-1387-4CA6-816F-3879F97B5CBC}" type="slidenum">
               <a:rPr lang="en-US"/>
-              <a:t>12</a:t>
+              <a:t>13</a:t>
             </a:fld>
             <a:endParaRPr lang="en-US"/>
           </a:p>
@@ -653,7 +654,7 @@
           <a:p>
             <a:fld id="{F7021451-1387-4CA6-816F-3879F97B5CBC}" type="slidenum">
               <a:rPr lang="en-US"/>
-              <a:t>13</a:t>
+              <a:t>14</a:t>
             </a:fld>
             <a:endParaRPr lang="en-US"/>
           </a:p>
@@ -737,7 +738,7 @@
           <a:p>
             <a:fld id="{F7021451-1387-4CA6-816F-3879F97B5CBC}" type="slidenum">
               <a:rPr lang="en-US"/>
-              <a:t>14</a:t>
+              <a:t>15</a:t>
             </a:fld>
             <a:endParaRPr lang="en-US"/>
           </a:p>
@@ -821,7 +822,7 @@
           <a:p>
             <a:fld id="{F7021451-1387-4CA6-816F-3879F97B5CBC}" type="slidenum">
               <a:rPr lang="en-US"/>
-              <a:t>15</a:t>
+              <a:t>16</a:t>
             </a:fld>
             <a:endParaRPr lang="en-US"/>
           </a:p>
@@ -905,7 +906,7 @@
           <a:p>
             <a:fld id="{F7021451-1387-4CA6-816F-3879F97B5CBC}" type="slidenum">
               <a:rPr lang="en-US"/>
-              <a:t>16</a:t>
+              <a:t>17</a:t>
             </a:fld>
             <a:endParaRPr lang="en-US"/>
           </a:p>
@@ -2047,7 +2048,7 @@
         </p:nvSpPr>
         <p:spPr>
           <a:xfrm>
-            <a:off x="457200" y="2926080"/>
+            <a:off x="365760" y="3008376"/>
             <a:ext cx="5212080" cy="402336"/>
           </a:xfrm>
           <a:prstGeom prst="rect">
@@ -2067,7 +2068,7 @@
           <a:bodyPr/>
           <a:lstStyle/>
           <a:p>
-            <a:endParaRPr lang="en-US"/>
+            <a:endParaRPr lang="en-US" dirty="0"/>
           </a:p>
         </p:txBody>
       </p:sp>
@@ -2096,50 +2097,13 @@
               <a:buNone/>
             </a:pPr>
             <a:r>
-              <a:rPr lang="en-US" sz="1400" dirty="0">
+              <a:rPr lang="it-IT" sz="1400" dirty="0">
                 <a:solidFill>
                   <a:srgbClr val="FFFFFF"/>
                 </a:solidFill>
               </a:rPr>
-              <a:t>Za odrasle i osobe starije životne dobi</a:t>
-            </a:r>
-            <a:endParaRPr lang="en-US" sz="1400" dirty="0"/>
-          </a:p>
-        </p:txBody>
-      </p:sp>
-      <p:sp>
-        <p:nvSpPr>
-          <p:cNvPr id="6" name="Text 4"/>
-          <p:cNvSpPr/>
-          <p:nvPr/>
-        </p:nvSpPr>
-        <p:spPr>
-          <a:xfrm>
-            <a:off x="457200" y="3456432"/>
-            <a:ext cx="5212080" cy="411480"/>
-          </a:xfrm>
-          <a:prstGeom prst="rect">
-            <a:avLst/>
-          </a:prstGeom>
-          <a:noFill/>
-          <a:ln/>
-        </p:spPr>
-        <p:txBody>
-          <a:bodyPr wrap="square" rtlCol="0" anchor="ctr"/>
-          <a:lstStyle/>
-          <a:p>
-            <a:pPr marL="0" indent="0">
-              <a:buNone/>
-            </a:pPr>
-            <a:r>
-              <a:rPr lang="en-US" sz="1100" i="1" dirty="0">
-                <a:solidFill>
-                  <a:srgbClr val="888888"/>
-                </a:solidFill>
-              </a:rPr>
               <a:t>Prepoznajte prijevaru · Zaštitite podatke · Budite sigurni online</a:t>
             </a:r>
-            <a:endParaRPr lang="en-US" sz="1100" dirty="0"/>
           </a:p>
         </p:txBody>
       </p:sp>
@@ -2284,6 +2248,184 @@
 </file>
 
 <file path=ppt/slides/slide10.xml><?xml version="1.0" encoding="utf-8"?>
+<p:sld xmlns:a="http://schemas.openxmlformats.org/drawingml/2006/main" xmlns:r="http://schemas.openxmlformats.org/officeDocument/2006/relationships" xmlns:p="http://schemas.openxmlformats.org/presentationml/2006/main">
+  <p:cSld>
+    <p:spTree>
+      <p:nvGrpSpPr>
+        <p:cNvPr id="1" name=""/>
+        <p:cNvGrpSpPr/>
+        <p:nvPr/>
+      </p:nvGrpSpPr>
+      <p:grpSpPr>
+        <a:xfrm>
+          <a:off x="0" y="0"/>
+          <a:ext cx="0" cy="0"/>
+          <a:chOff x="0" y="0"/>
+          <a:chExt cx="0" cy="0"/>
+        </a:xfrm>
+      </p:grpSpPr>
+      <p:pic>
+        <p:nvPicPr>
+          <p:cNvPr id="3" name="Picture 2">
+            <a:extLst>
+              <a:ext uri="{FF2B5EF4-FFF2-40B4-BE49-F238E27FC236}">
+                <a16:creationId xmlns:a16="http://schemas.microsoft.com/office/drawing/2014/main" id="{D06BF0CA-184E-648D-E3FD-594980805770}"/>
+              </a:ext>
+            </a:extLst>
+          </p:cNvPr>
+          <p:cNvPicPr>
+            <a:picLocks noChangeAspect="1"/>
+          </p:cNvPicPr>
+          <p:nvPr/>
+        </p:nvPicPr>
+        <p:blipFill>
+          <a:blip r:embed="rId2"/>
+          <a:stretch>
+            <a:fillRect/>
+          </a:stretch>
+        </p:blipFill>
+        <p:spPr>
+          <a:xfrm>
+            <a:off x="0" y="0"/>
+            <a:ext cx="9144000" cy="5143500"/>
+          </a:xfrm>
+          <a:prstGeom prst="rect">
+            <a:avLst/>
+          </a:prstGeom>
+        </p:spPr>
+      </p:pic>
+      <p:pic>
+        <p:nvPicPr>
+          <p:cNvPr id="6" name="Picture 5">
+            <a:extLst>
+              <a:ext uri="{FF2B5EF4-FFF2-40B4-BE49-F238E27FC236}">
+                <a16:creationId xmlns:a16="http://schemas.microsoft.com/office/drawing/2014/main" id="{B4255DF2-EF8B-D9CC-AAE1-CEB6D83CB1E4}"/>
+              </a:ext>
+            </a:extLst>
+          </p:cNvPr>
+          <p:cNvPicPr>
+            <a:picLocks noChangeAspect="1"/>
+          </p:cNvPicPr>
+          <p:nvPr/>
+        </p:nvPicPr>
+        <p:blipFill>
+          <a:blip r:embed="rId3"/>
+          <a:stretch>
+            <a:fillRect/>
+          </a:stretch>
+        </p:blipFill>
+        <p:spPr>
+          <a:xfrm>
+            <a:off x="265314" y="3838308"/>
+            <a:ext cx="5003084" cy="441266"/>
+          </a:xfrm>
+          <a:prstGeom prst="rect">
+            <a:avLst/>
+          </a:prstGeom>
+        </p:spPr>
+      </p:pic>
+      <p:sp>
+        <p:nvSpPr>
+          <p:cNvPr id="7" name="TextBox 6">
+            <a:extLst>
+              <a:ext uri="{FF2B5EF4-FFF2-40B4-BE49-F238E27FC236}">
+                <a16:creationId xmlns:a16="http://schemas.microsoft.com/office/drawing/2014/main" id="{D67787A6-13EB-6ACD-DCC4-56AEA9CAEB36}"/>
+              </a:ext>
+            </a:extLst>
+          </p:cNvPr>
+          <p:cNvSpPr txBox="1"/>
+          <p:nvPr/>
+        </p:nvSpPr>
+        <p:spPr>
+          <a:xfrm>
+            <a:off x="3778713" y="4650722"/>
+            <a:ext cx="2701765" cy="307777"/>
+          </a:xfrm>
+          <a:prstGeom prst="rect">
+            <a:avLst/>
+          </a:prstGeom>
+          <a:noFill/>
+        </p:spPr>
+        <p:txBody>
+          <a:bodyPr wrap="none" rtlCol="0">
+            <a:spAutoFit/>
+          </a:bodyPr>
+          <a:lstStyle/>
+          <a:p>
+            <a:r>
+              <a:rPr lang="en-US" sz="1400" i="1" dirty="0" err="1">
+                <a:solidFill>
+                  <a:schemeClr val="bg2">
+                    <a:lumMod val="25000"/>
+                  </a:schemeClr>
+                </a:solidFill>
+              </a:rPr>
+              <a:t>Preporučeno</a:t>
+            </a:r>
+            <a:r>
+              <a:rPr lang="en-US" sz="1400" i="1" dirty="0">
+                <a:solidFill>
+                  <a:schemeClr val="bg2">
+                    <a:lumMod val="25000"/>
+                  </a:schemeClr>
+                </a:solidFill>
+              </a:rPr>
+              <a:t> je </a:t>
+            </a:r>
+            <a:r>
+              <a:rPr lang="en-US" sz="1400" i="1" dirty="0" err="1">
+                <a:solidFill>
+                  <a:schemeClr val="bg2">
+                    <a:lumMod val="25000"/>
+                  </a:schemeClr>
+                </a:solidFill>
+              </a:rPr>
+              <a:t>plaćanje</a:t>
+            </a:r>
+            <a:r>
+              <a:rPr lang="en-US" sz="1400" i="1" dirty="0">
+                <a:solidFill>
+                  <a:schemeClr val="bg2">
+                    <a:lumMod val="25000"/>
+                  </a:schemeClr>
+                </a:solidFill>
+              </a:rPr>
+              <a:t> </a:t>
+            </a:r>
+            <a:r>
+              <a:rPr lang="en-US" sz="1400" i="1" dirty="0" err="1">
+                <a:solidFill>
+                  <a:schemeClr val="bg2">
+                    <a:lumMod val="25000"/>
+                  </a:schemeClr>
+                </a:solidFill>
+              </a:rPr>
+              <a:t>pouzećem</a:t>
+            </a:r>
+            <a:endParaRPr lang="en-US" sz="1400" i="1" dirty="0">
+              <a:solidFill>
+                <a:schemeClr val="bg2">
+                  <a:lumMod val="25000"/>
+                </a:schemeClr>
+              </a:solidFill>
+            </a:endParaRPr>
+          </a:p>
+        </p:txBody>
+      </p:sp>
+    </p:spTree>
+    <p:extLst>
+      <p:ext uri="{BB962C8B-B14F-4D97-AF65-F5344CB8AC3E}">
+        <p14:creationId xmlns:p14="http://schemas.microsoft.com/office/powerpoint/2010/main" val="1874175030"/>
+      </p:ext>
+    </p:extLst>
+  </p:cSld>
+  <p:clrMapOvr>
+    <a:masterClrMapping/>
+  </p:clrMapOvr>
+</p:sld>
+</file>
+
+<file path=ppt/slides/slide11.xml><?xml version="1.0" encoding="utf-8"?>
 <p:sld xmlns:a="http://schemas.openxmlformats.org/drawingml/2006/main" xmlns:r="http://schemas.openxmlformats.org/officeDocument/2006/relationships" xmlns:p="http://schemas.openxmlformats.org/presentationml/2006/main">
   <p:cSld name="Slide 9">
     <p:bg>
@@ -3160,7 +3302,7 @@
 </p:sld>
 </file>
 
-<file path=ppt/slides/slide11.xml><?xml version="1.0" encoding="utf-8"?>
+<file path=ppt/slides/slide12.xml><?xml version="1.0" encoding="utf-8"?>
 <p:sld xmlns:a="http://schemas.openxmlformats.org/drawingml/2006/main" xmlns:r="http://schemas.openxmlformats.org/officeDocument/2006/relationships" xmlns:p="http://schemas.openxmlformats.org/presentationml/2006/main">
   <p:cSld name="Slide 10">
     <p:bg>
@@ -3689,7 +3831,7 @@
 </p:sld>
 </file>
 
-<file path=ppt/slides/slide12.xml><?xml version="1.0" encoding="utf-8"?>
+<file path=ppt/slides/slide13.xml><?xml version="1.0" encoding="utf-8"?>
 <p:sld xmlns:a="http://schemas.openxmlformats.org/drawingml/2006/main" xmlns:r="http://schemas.openxmlformats.org/officeDocument/2006/relationships" xmlns:p="http://schemas.openxmlformats.org/presentationml/2006/main">
   <p:cSld name="Slide 11">
     <p:bg>
@@ -4486,7 +4628,7 @@
 </p:sld>
 </file>
 
-<file path=ppt/slides/slide13.xml><?xml version="1.0" encoding="utf-8"?>
+<file path=ppt/slides/slide14.xml><?xml version="1.0" encoding="utf-8"?>
 <p:sld xmlns:a="http://schemas.openxmlformats.org/drawingml/2006/main" xmlns:r="http://schemas.openxmlformats.org/officeDocument/2006/relationships" xmlns:p="http://schemas.openxmlformats.org/presentationml/2006/main">
   <p:cSld name="Slide 12">
     <p:bg>
@@ -5363,7 +5505,7 @@
 </p:sld>
 </file>
 
-<file path=ppt/slides/slide14.xml><?xml version="1.0" encoding="utf-8"?>
+<file path=ppt/slides/slide15.xml><?xml version="1.0" encoding="utf-8"?>
 <p:sld xmlns:a="http://schemas.openxmlformats.org/drawingml/2006/main" xmlns:r="http://schemas.openxmlformats.org/officeDocument/2006/relationships" xmlns:p="http://schemas.openxmlformats.org/presentationml/2006/main">
   <p:cSld name="Slide 13">
     <p:bg>
@@ -5472,7 +5614,7 @@
         </p:nvGraphicFramePr>
         <p:xfrm>
           <a:off x="274320" y="804672"/>
-          <a:ext cx="8595360" cy="914400"/>
+          <a:ext cx="8595360" cy="4389120"/>
         </p:xfrm>
         <a:graphic>
           <a:graphicData uri="http://schemas.openxmlformats.org/drawingml/2006/table">
@@ -7033,7 +7175,7 @@
 </p:sld>
 </file>
 
-<file path=ppt/slides/slide15.xml><?xml version="1.0" encoding="utf-8"?>
+<file path=ppt/slides/slide16.xml><?xml version="1.0" encoding="utf-8"?>
 <p:sld xmlns:a="http://schemas.openxmlformats.org/drawingml/2006/main" xmlns:r="http://schemas.openxmlformats.org/officeDocument/2006/relationships" xmlns:p="http://schemas.openxmlformats.org/presentationml/2006/main">
   <p:cSld name="Slide 14">
     <p:bg>
@@ -7580,7 +7722,7 @@
 </p:sld>
 </file>
 
-<file path=ppt/slides/slide16.xml><?xml version="1.0" encoding="utf-8"?>
+<file path=ppt/slides/slide17.xml><?xml version="1.0" encoding="utf-8"?>
 <p:sld xmlns:a="http://schemas.openxmlformats.org/drawingml/2006/main" xmlns:r="http://schemas.openxmlformats.org/officeDocument/2006/relationships" xmlns:p="http://schemas.openxmlformats.org/presentationml/2006/main">
   <p:cSld name="Slide 15">
     <p:bg>
@@ -7873,7 +8015,7 @@
         </p:nvSpPr>
         <p:spPr>
           <a:xfrm>
-            <a:off x="457200" y="4736592"/>
+            <a:off x="457200" y="4521708"/>
             <a:ext cx="5486400" cy="274320"/>
           </a:xfrm>
           <a:prstGeom prst="rect">
@@ -9280,7 +9422,39 @@
                   <a:srgbClr val="444444"/>
                 </a:solidFill>
               </a:rPr>
-              <a:t> poruka: nitko nije presmetan da postane žrtva. Znanje je jedina zaštita.</a:t>
+              <a:t> poruka: nitko </a:t>
+            </a:r>
+            <a:r>
+              <a:rPr lang="en-US" dirty="0" err="1">
+                <a:solidFill>
+                  <a:srgbClr val="444444"/>
+                </a:solidFill>
+              </a:rPr>
+              <a:t>nije</a:t>
+            </a:r>
+            <a:r>
+              <a:rPr lang="en-US" dirty="0">
+                <a:solidFill>
+                  <a:srgbClr val="444444"/>
+                </a:solidFill>
+              </a:rPr>
+              <a:t> </a:t>
+            </a:r>
+            <a:r>
+              <a:rPr lang="en-US" dirty="0" err="1">
+                <a:solidFill>
+                  <a:srgbClr val="444444"/>
+                </a:solidFill>
+              </a:rPr>
+              <a:t>prepametan</a:t>
+            </a:r>
+            <a:r>
+              <a:rPr lang="en-US" dirty="0">
+                <a:solidFill>
+                  <a:srgbClr val="444444"/>
+                </a:solidFill>
+              </a:rPr>
+              <a:t> da postane žrtva. Znanje je jedina zaštita.</a:t>
             </a:r>
             <a:endParaRPr lang="en-US" dirty="0"/>
           </a:p>

</xml_diff>